<commit_message>
Powerpoint practica Lorena y Maria
</commit_message>
<xml_diff>
--- a/LabBook_20_lorena y maria.pptx
+++ b/LabBook_20_lorena y maria.pptx
@@ -161,7 +161,7 @@
   <pc:docChgLst>
     <pc:chgData name="Lorena Gimeno" userId="548ce772763c7a5c" providerId="LiveId" clId="{24A47F1E-ED8B-4BF7-8ED5-668CDAADF216}"/>
     <pc:docChg chg="custSel modSld">
-      <pc:chgData name="Lorena Gimeno" userId="548ce772763c7a5c" providerId="LiveId" clId="{24A47F1E-ED8B-4BF7-8ED5-668CDAADF216}" dt="2026-05-03T16:10:15.234" v="51" actId="20577"/>
+      <pc:chgData name="Lorena Gimeno" userId="548ce772763c7a5c" providerId="LiveId" clId="{24A47F1E-ED8B-4BF7-8ED5-668CDAADF216}" dt="2026-05-03T16:53:52.671" v="55" actId="14100"/>
       <pc:docMkLst>
         <pc:docMk/>
       </pc:docMkLst>
@@ -308,6 +308,36 @@
             <pc:docMk/>
             <pc:sldMk cId="699864314" sldId="301"/>
             <ac:picMk id="9" creationId="{2E0D2D9C-20DC-D1CF-F6F9-0E9ECD81AE86}"/>
+          </ac:picMkLst>
+        </pc:picChg>
+      </pc:sldChg>
+      <pc:sldChg chg="modSp mod">
+        <pc:chgData name="Lorena Gimeno" userId="548ce772763c7a5c" providerId="LiveId" clId="{24A47F1E-ED8B-4BF7-8ED5-668CDAADF216}" dt="2026-05-03T16:53:52.671" v="55" actId="14100"/>
+        <pc:sldMkLst>
+          <pc:docMk/>
+          <pc:sldMk cId="1558326841" sldId="303"/>
+        </pc:sldMkLst>
+        <pc:picChg chg="mod">
+          <ac:chgData name="Lorena Gimeno" userId="548ce772763c7a5c" providerId="LiveId" clId="{24A47F1E-ED8B-4BF7-8ED5-668CDAADF216}" dt="2026-05-03T16:53:52.671" v="55" actId="14100"/>
+          <ac:picMkLst>
+            <pc:docMk/>
+            <pc:sldMk cId="1558326841" sldId="303"/>
+            <ac:picMk id="20" creationId="{9817408F-E8F4-1712-4477-3F151C7DC6FC}"/>
+          </ac:picMkLst>
+        </pc:picChg>
+      </pc:sldChg>
+      <pc:sldChg chg="modSp mod">
+        <pc:chgData name="Lorena Gimeno" userId="548ce772763c7a5c" providerId="LiveId" clId="{24A47F1E-ED8B-4BF7-8ED5-668CDAADF216}" dt="2026-05-03T16:53:44.498" v="53" actId="1076"/>
+        <pc:sldMkLst>
+          <pc:docMk/>
+          <pc:sldMk cId="4090700512" sldId="305"/>
+        </pc:sldMkLst>
+        <pc:picChg chg="mod">
+          <ac:chgData name="Lorena Gimeno" userId="548ce772763c7a5c" providerId="LiveId" clId="{24A47F1E-ED8B-4BF7-8ED5-668CDAADF216}" dt="2026-05-03T16:53:44.498" v="53" actId="1076"/>
+          <ac:picMkLst>
+            <pc:docMk/>
+            <pc:sldMk cId="4090700512" sldId="305"/>
+            <ac:picMk id="17" creationId="{4E59F9E9-BF55-DBA3-3166-2FB337B2CE36}"/>
           </ac:picMkLst>
         </pc:picChg>
       </pc:sldChg>
@@ -14905,8 +14935,8 @@
         </p:blipFill>
         <p:spPr>
           <a:xfrm>
-            <a:off x="8077200" y="1652470"/>
-            <a:ext cx="3048000" cy="814033"/>
+            <a:off x="7747001" y="1653944"/>
+            <a:ext cx="3741661" cy="999290"/>
           </a:xfrm>
           <a:prstGeom prst="rect">
             <a:avLst/>
@@ -17406,7 +17436,7 @@
         </p:blipFill>
         <p:spPr>
           <a:xfrm>
-            <a:off x="8325239" y="2536619"/>
+            <a:off x="8287333" y="2551378"/>
             <a:ext cx="3512406" cy="1985273"/>
           </a:xfrm>
           <a:prstGeom prst="rect">

</xml_diff>